<commit_message>
PINNs: mas comentarios en el nucleo y tareas convertidas en miniproyectos
el codigo que resuelve la PINN (red, autograd, las tres perdidas, las dos fases
del optimizador) queda comentado paso a paso. las tareas pasan a ser cuatro
miniproyectos donde la arquitectura ya esta hecha: una funcion experimento()
recorre datos-entrenamiento-diagnostico y solo hay que cambiarle parametros.

se entrenan sin regalar la condicion inicial, porque con ella la fisica sola ya
determina la solucion y quitar datos no cambiaba nada. anade la metrica
misfit/sigma, que es lo que de verdad delata una fisica equivocada: el residuo
no distingue los dos casos y el misfit se atasca 3x por encima del ruido.

quita el README.
</commit_message>
<xml_diff>
--- a/PINNsClass/Presentacion_PINNs_Fisica_Solar.pptx
+++ b/PINNsClass/Presentacion_PINNs_Fisica_Solar.pptx
@@ -14192,7 +14192,7 @@
                 </a:solidFill>
                 <a:latin typeface="Open Sans"/>
               </a:rPr>
-              <a:t>1,621× más rápido</a:t>
+              <a:t>1,641× más rápido</a:t>
             </a:r>
             <a:r>
               <a:rPr sz="1500" b="0" i="0">
@@ -14651,7 +14651,7 @@
                           </a:solidFill>
                           <a:latin typeface="Open Sans"/>
                         </a:rPr>
-                        <a:t>21 ms</a:t>
+                        <a:t>20 ms</a:t>
                       </a:r>
                     </a:p>
                   </a:txBody>
@@ -14674,7 +14674,7 @@
                           </a:solidFill>
                           <a:latin typeface="Open Sans"/>
                         </a:rPr>
-                        <a:t>34 s</a:t>
+                        <a:t>33 s</a:t>
                       </a:r>
                     </a:p>
                   </a:txBody>

</xml_diff>